<commit_message>
Add smart offline & mobile mock fallback for Netlify cloud deployment
</commit_message>
<xml_diff>
--- a/document/CareConnect_EHR_Presentation.pptx
+++ b/document/CareConnect_EHR_Presentation.pptx
@@ -1,21 +1,21 @@
 
 <file path=ppt/presentation.xml><?xml version="1.0" encoding="utf-8"?>
-<p:presentation xmlns:a="http://schemas.openxmlformats.org/drawingml/2006/main" xmlns:r="http://schemas.openxmlformats.org/officeDocument/2006/relationships" xmlns:p="http://schemas.openxmlformats.org/presentationml/2006/main" saveSubsetFonts="1" autoCompressPictures="0">
+<p:presentation xmlns:a="http://schemas.openxmlformats.org/drawingml/2006/main" xmlns:r="http://schemas.openxmlformats.org/officeDocument/2006/relationships" xmlns:p="http://schemas.openxmlformats.org/presentationml/2006/main" autoCompressPictures="0">
   <p:sldMasterIdLst>
     <p:sldMasterId id="2147483648" r:id="rId1"/>
   </p:sldMasterIdLst>
   <p:sldIdLst>
-    <p:sldId id="256" r:id="rId7"/>
-    <p:sldId id="257" r:id="rId8"/>
-    <p:sldId id="258" r:id="rId9"/>
-    <p:sldId id="259" r:id="rId10"/>
-    <p:sldId id="260" r:id="rId11"/>
-    <p:sldId id="261" r:id="rId12"/>
-    <p:sldId id="262" r:id="rId13"/>
-    <p:sldId id="263" r:id="rId14"/>
-    <p:sldId id="264" r:id="rId15"/>
+    <p:sldId id="256" r:id="rId3"/>
+    <p:sldId id="257" r:id="rId4"/>
+    <p:sldId id="258" r:id="rId5"/>
+    <p:sldId id="259" r:id="rId6"/>
+    <p:sldId id="260" r:id="rId7"/>
+    <p:sldId id="261" r:id="rId8"/>
+    <p:sldId id="262" r:id="rId9"/>
+    <p:sldId id="263" r:id="rId10"/>
+    <p:sldId id="264" r:id="rId11"/>
   </p:sldIdLst>
-  <p:sldSz cx="12191695" cy="6858000" type="screen4x3"/>
+  <p:sldSz cx="12191365" cy="6858000" type="screen4x3"/>
   <p:notesSz cx="6858000" cy="9144000"/>
   <p:defaultTextStyle>
     <a:defPPr>
@@ -112,6 +112,22 @@
       </a:defRPr>
     </a:lvl9pPr>
   </p:defaultTextStyle>
+  <p:extLst>
+    <p:ext uri="{EFAFB233-063F-42B5-8137-9DF3F51BA10A}">
+      <p15:sldGuideLst xmlns:p15="http://schemas.microsoft.com/office/powerpoint/2012/main">
+        <p15:guide id="1" orient="horz" pos="2160" userDrawn="1">
+          <p15:clr>
+            <a:srgbClr val="A4A3A4"/>
+          </p15:clr>
+        </p15:guide>
+        <p15:guide id="2" pos="2880" userDrawn="1">
+          <p15:clr>
+            <a:srgbClr val="A4A3A4"/>
+          </p15:clr>
+        </p15:guide>
+      </p15:sldGuideLst>
+    </p:ext>
+  </p:extLst>
 </p:presentation>
 </file>
 
@@ -296,7 +312,6 @@
           <a:p>
             <a:fld id="{5BCAD085-E8A6-8845-BD4E-CB4CCA059FC4}" type="datetimeFigureOut">
               <a:rPr lang="en-US" smtClean="0"/>
-              <a:t>1/27/13</a:t>
             </a:fld>
             <a:endParaRPr lang="en-US"/>
           </a:p>
@@ -338,18 +353,12 @@
           <a:p>
             <a:fld id="{C1FF6DA9-008F-8B48-92A6-B652298478BF}" type="slidenum">
               <a:rPr lang="en-US" smtClean="0"/>
-              <a:t>‹#›</a:t>
             </a:fld>
             <a:endParaRPr lang="en-US"/>
           </a:p>
         </p:txBody>
       </p:sp>
     </p:spTree>
-    <p:extLst>
-      <p:ext uri="{BB962C8B-B14F-4D97-AF65-F5344CB8AC3E}">
-        <p14:creationId xmlns:p14="http://schemas.microsoft.com/office/powerpoint/2010/main" val="3168075583"/>
-      </p:ext>
-    </p:extLst>
   </p:cSld>
   <p:clrMapOvr>
     <a:masterClrMapping/>
@@ -417,6 +426,7 @@
               <a:rPr lang="en-US" smtClean="0"/>
               <a:t>Click to edit Master text styles</a:t>
             </a:r>
+            <a:endParaRPr lang="en-US" smtClean="0"/>
           </a:p>
           <a:p>
             <a:pPr lvl="1"/>
@@ -424,6 +434,7 @@
               <a:rPr lang="en-US" smtClean="0"/>
               <a:t>Second level</a:t>
             </a:r>
+            <a:endParaRPr lang="en-US" smtClean="0"/>
           </a:p>
           <a:p>
             <a:pPr lvl="2"/>
@@ -431,6 +442,7 @@
               <a:rPr lang="en-US" smtClean="0"/>
               <a:t>Third level</a:t>
             </a:r>
+            <a:endParaRPr lang="en-US" smtClean="0"/>
           </a:p>
           <a:p>
             <a:pPr lvl="3"/>
@@ -438,6 +450,7 @@
               <a:rPr lang="en-US" smtClean="0"/>
               <a:t>Fourth level</a:t>
             </a:r>
+            <a:endParaRPr lang="en-US" smtClean="0"/>
           </a:p>
           <a:p>
             <a:pPr lvl="4"/>
@@ -466,7 +479,6 @@
           <a:p>
             <a:fld id="{5BCAD085-E8A6-8845-BD4E-CB4CCA059FC4}" type="datetimeFigureOut">
               <a:rPr lang="en-US" smtClean="0"/>
-              <a:t>1/27/13</a:t>
             </a:fld>
             <a:endParaRPr lang="en-US"/>
           </a:p>
@@ -508,18 +520,12 @@
           <a:p>
             <a:fld id="{C1FF6DA9-008F-8B48-92A6-B652298478BF}" type="slidenum">
               <a:rPr lang="en-US" smtClean="0"/>
-              <a:t>‹#›</a:t>
             </a:fld>
             <a:endParaRPr lang="en-US"/>
           </a:p>
         </p:txBody>
       </p:sp>
     </p:spTree>
-    <p:extLst>
-      <p:ext uri="{BB962C8B-B14F-4D97-AF65-F5344CB8AC3E}">
-        <p14:creationId xmlns:p14="http://schemas.microsoft.com/office/powerpoint/2010/main" val="2910927964"/>
-      </p:ext>
-    </p:extLst>
   </p:cSld>
   <p:clrMapOvr>
     <a:masterClrMapping/>
@@ -597,6 +603,7 @@
               <a:rPr lang="en-US" smtClean="0"/>
               <a:t>Click to edit Master text styles</a:t>
             </a:r>
+            <a:endParaRPr lang="en-US" smtClean="0"/>
           </a:p>
           <a:p>
             <a:pPr lvl="1"/>
@@ -604,6 +611,7 @@
               <a:rPr lang="en-US" smtClean="0"/>
               <a:t>Second level</a:t>
             </a:r>
+            <a:endParaRPr lang="en-US" smtClean="0"/>
           </a:p>
           <a:p>
             <a:pPr lvl="2"/>
@@ -611,6 +619,7 @@
               <a:rPr lang="en-US" smtClean="0"/>
               <a:t>Third level</a:t>
             </a:r>
+            <a:endParaRPr lang="en-US" smtClean="0"/>
           </a:p>
           <a:p>
             <a:pPr lvl="3"/>
@@ -618,6 +627,7 @@
               <a:rPr lang="en-US" smtClean="0"/>
               <a:t>Fourth level</a:t>
             </a:r>
+            <a:endParaRPr lang="en-US" smtClean="0"/>
           </a:p>
           <a:p>
             <a:pPr lvl="4"/>
@@ -646,7 +656,6 @@
           <a:p>
             <a:fld id="{5BCAD085-E8A6-8845-BD4E-CB4CCA059FC4}" type="datetimeFigureOut">
               <a:rPr lang="en-US" smtClean="0"/>
-              <a:t>1/27/13</a:t>
             </a:fld>
             <a:endParaRPr lang="en-US"/>
           </a:p>
@@ -688,18 +697,12 @@
           <a:p>
             <a:fld id="{C1FF6DA9-008F-8B48-92A6-B652298478BF}" type="slidenum">
               <a:rPr lang="en-US" smtClean="0"/>
-              <a:t>‹#›</a:t>
             </a:fld>
             <a:endParaRPr lang="en-US"/>
           </a:p>
         </p:txBody>
       </p:sp>
     </p:spTree>
-    <p:extLst>
-      <p:ext uri="{BB962C8B-B14F-4D97-AF65-F5344CB8AC3E}">
-        <p14:creationId xmlns:p14="http://schemas.microsoft.com/office/powerpoint/2010/main" val="3612223792"/>
-      </p:ext>
-    </p:extLst>
   </p:cSld>
   <p:clrMapOvr>
     <a:masterClrMapping/>
@@ -767,6 +770,7 @@
               <a:rPr lang="en-US" smtClean="0"/>
               <a:t>Click to edit Master text styles</a:t>
             </a:r>
+            <a:endParaRPr lang="en-US" smtClean="0"/>
           </a:p>
           <a:p>
             <a:pPr lvl="1"/>
@@ -774,6 +778,7 @@
               <a:rPr lang="en-US" smtClean="0"/>
               <a:t>Second level</a:t>
             </a:r>
+            <a:endParaRPr lang="en-US" smtClean="0"/>
           </a:p>
           <a:p>
             <a:pPr lvl="2"/>
@@ -781,6 +786,7 @@
               <a:rPr lang="en-US" smtClean="0"/>
               <a:t>Third level</a:t>
             </a:r>
+            <a:endParaRPr lang="en-US" smtClean="0"/>
           </a:p>
           <a:p>
             <a:pPr lvl="3"/>
@@ -788,6 +794,7 @@
               <a:rPr lang="en-US" smtClean="0"/>
               <a:t>Fourth level</a:t>
             </a:r>
+            <a:endParaRPr lang="en-US" smtClean="0"/>
           </a:p>
           <a:p>
             <a:pPr lvl="4"/>
@@ -816,7 +823,6 @@
           <a:p>
             <a:fld id="{5BCAD085-E8A6-8845-BD4E-CB4CCA059FC4}" type="datetimeFigureOut">
               <a:rPr lang="en-US" smtClean="0"/>
-              <a:t>1/27/13</a:t>
             </a:fld>
             <a:endParaRPr lang="en-US"/>
           </a:p>
@@ -858,18 +864,12 @@
           <a:p>
             <a:fld id="{C1FF6DA9-008F-8B48-92A6-B652298478BF}" type="slidenum">
               <a:rPr lang="en-US" smtClean="0"/>
-              <a:t>‹#›</a:t>
             </a:fld>
             <a:endParaRPr lang="en-US"/>
           </a:p>
         </p:txBody>
       </p:sp>
     </p:spTree>
-    <p:extLst>
-      <p:ext uri="{BB962C8B-B14F-4D97-AF65-F5344CB8AC3E}">
-        <p14:creationId xmlns:p14="http://schemas.microsoft.com/office/powerpoint/2010/main" val="2614314258"/>
-      </p:ext>
-    </p:extLst>
   </p:cSld>
   <p:clrMapOvr>
     <a:masterClrMapping/>
@@ -1042,6 +1042,7 @@
               <a:rPr lang="en-US" smtClean="0"/>
               <a:t>Click to edit Master text styles</a:t>
             </a:r>
+            <a:endParaRPr lang="en-US" smtClean="0"/>
           </a:p>
         </p:txBody>
       </p:sp>
@@ -1062,7 +1063,6 @@
           <a:p>
             <a:fld id="{5BCAD085-E8A6-8845-BD4E-CB4CCA059FC4}" type="datetimeFigureOut">
               <a:rPr lang="en-US" smtClean="0"/>
-              <a:t>1/27/13</a:t>
             </a:fld>
             <a:endParaRPr lang="en-US"/>
           </a:p>
@@ -1104,18 +1104,12 @@
           <a:p>
             <a:fld id="{C1FF6DA9-008F-8B48-92A6-B652298478BF}" type="slidenum">
               <a:rPr lang="en-US" smtClean="0"/>
-              <a:t>‹#›</a:t>
             </a:fld>
             <a:endParaRPr lang="en-US"/>
           </a:p>
         </p:txBody>
       </p:sp>
     </p:spTree>
-    <p:extLst>
-      <p:ext uri="{BB962C8B-B14F-4D97-AF65-F5344CB8AC3E}">
-        <p14:creationId xmlns:p14="http://schemas.microsoft.com/office/powerpoint/2010/main" val="960648375"/>
-      </p:ext>
-    </p:extLst>
   </p:cSld>
   <p:clrMapOvr>
     <a:masterClrMapping/>
@@ -1216,6 +1210,7 @@
               <a:rPr lang="en-US" smtClean="0"/>
               <a:t>Click to edit Master text styles</a:t>
             </a:r>
+            <a:endParaRPr lang="en-US" smtClean="0"/>
           </a:p>
           <a:p>
             <a:pPr lvl="1"/>
@@ -1223,6 +1218,7 @@
               <a:rPr lang="en-US" smtClean="0"/>
               <a:t>Second level</a:t>
             </a:r>
+            <a:endParaRPr lang="en-US" smtClean="0"/>
           </a:p>
           <a:p>
             <a:pPr lvl="2"/>
@@ -1230,6 +1226,7 @@
               <a:rPr lang="en-US" smtClean="0"/>
               <a:t>Third level</a:t>
             </a:r>
+            <a:endParaRPr lang="en-US" smtClean="0"/>
           </a:p>
           <a:p>
             <a:pPr lvl="3"/>
@@ -1237,6 +1234,7 @@
               <a:rPr lang="en-US" smtClean="0"/>
               <a:t>Fourth level</a:t>
             </a:r>
+            <a:endParaRPr lang="en-US" smtClean="0"/>
           </a:p>
           <a:p>
             <a:pPr lvl="4"/>
@@ -1301,6 +1299,7 @@
               <a:rPr lang="en-US" smtClean="0"/>
               <a:t>Click to edit Master text styles</a:t>
             </a:r>
+            <a:endParaRPr lang="en-US" smtClean="0"/>
           </a:p>
           <a:p>
             <a:pPr lvl="1"/>
@@ -1308,6 +1307,7 @@
               <a:rPr lang="en-US" smtClean="0"/>
               <a:t>Second level</a:t>
             </a:r>
+            <a:endParaRPr lang="en-US" smtClean="0"/>
           </a:p>
           <a:p>
             <a:pPr lvl="2"/>
@@ -1315,6 +1315,7 @@
               <a:rPr lang="en-US" smtClean="0"/>
               <a:t>Third level</a:t>
             </a:r>
+            <a:endParaRPr lang="en-US" smtClean="0"/>
           </a:p>
           <a:p>
             <a:pPr lvl="3"/>
@@ -1322,6 +1323,7 @@
               <a:rPr lang="en-US" smtClean="0"/>
               <a:t>Fourth level</a:t>
             </a:r>
+            <a:endParaRPr lang="en-US" smtClean="0"/>
           </a:p>
           <a:p>
             <a:pPr lvl="4"/>
@@ -1350,7 +1352,6 @@
           <a:p>
             <a:fld id="{5BCAD085-E8A6-8845-BD4E-CB4CCA059FC4}" type="datetimeFigureOut">
               <a:rPr lang="en-US" smtClean="0"/>
-              <a:t>1/27/13</a:t>
             </a:fld>
             <a:endParaRPr lang="en-US"/>
           </a:p>
@@ -1392,18 +1393,12 @@
           <a:p>
             <a:fld id="{C1FF6DA9-008F-8B48-92A6-B652298478BF}" type="slidenum">
               <a:rPr lang="en-US" smtClean="0"/>
-              <a:t>‹#›</a:t>
             </a:fld>
             <a:endParaRPr lang="en-US"/>
           </a:p>
         </p:txBody>
       </p:sp>
     </p:spTree>
-    <p:extLst>
-      <p:ext uri="{BB962C8B-B14F-4D97-AF65-F5344CB8AC3E}">
-        <p14:creationId xmlns:p14="http://schemas.microsoft.com/office/powerpoint/2010/main" val="2782244947"/>
-      </p:ext>
-    </p:extLst>
   </p:cSld>
   <p:clrMapOvr>
     <a:masterClrMapping/>
@@ -1517,6 +1512,7 @@
               <a:rPr lang="en-US" smtClean="0"/>
               <a:t>Click to edit Master text styles</a:t>
             </a:r>
+            <a:endParaRPr lang="en-US" smtClean="0"/>
           </a:p>
         </p:txBody>
       </p:sp>
@@ -1573,6 +1569,7 @@
               <a:rPr lang="en-US" smtClean="0"/>
               <a:t>Click to edit Master text styles</a:t>
             </a:r>
+            <a:endParaRPr lang="en-US" smtClean="0"/>
           </a:p>
           <a:p>
             <a:pPr lvl="1"/>
@@ -1580,6 +1577,7 @@
               <a:rPr lang="en-US" smtClean="0"/>
               <a:t>Second level</a:t>
             </a:r>
+            <a:endParaRPr lang="en-US" smtClean="0"/>
           </a:p>
           <a:p>
             <a:pPr lvl="2"/>
@@ -1587,6 +1585,7 @@
               <a:rPr lang="en-US" smtClean="0"/>
               <a:t>Third level</a:t>
             </a:r>
+            <a:endParaRPr lang="en-US" smtClean="0"/>
           </a:p>
           <a:p>
             <a:pPr lvl="3"/>
@@ -1594,6 +1593,7 @@
               <a:rPr lang="en-US" smtClean="0"/>
               <a:t>Fourth level</a:t>
             </a:r>
+            <a:endParaRPr lang="en-US" smtClean="0"/>
           </a:p>
           <a:p>
             <a:pPr lvl="4"/>
@@ -1667,6 +1667,7 @@
               <a:rPr lang="en-US" smtClean="0"/>
               <a:t>Click to edit Master text styles</a:t>
             </a:r>
+            <a:endParaRPr lang="en-US" smtClean="0"/>
           </a:p>
         </p:txBody>
       </p:sp>
@@ -1723,6 +1724,7 @@
               <a:rPr lang="en-US" smtClean="0"/>
               <a:t>Click to edit Master text styles</a:t>
             </a:r>
+            <a:endParaRPr lang="en-US" smtClean="0"/>
           </a:p>
           <a:p>
             <a:pPr lvl="1"/>
@@ -1730,6 +1732,7 @@
               <a:rPr lang="en-US" smtClean="0"/>
               <a:t>Second level</a:t>
             </a:r>
+            <a:endParaRPr lang="en-US" smtClean="0"/>
           </a:p>
           <a:p>
             <a:pPr lvl="2"/>
@@ -1737,6 +1740,7 @@
               <a:rPr lang="en-US" smtClean="0"/>
               <a:t>Third level</a:t>
             </a:r>
+            <a:endParaRPr lang="en-US" smtClean="0"/>
           </a:p>
           <a:p>
             <a:pPr lvl="3"/>
@@ -1744,6 +1748,7 @@
               <a:rPr lang="en-US" smtClean="0"/>
               <a:t>Fourth level</a:t>
             </a:r>
+            <a:endParaRPr lang="en-US" smtClean="0"/>
           </a:p>
           <a:p>
             <a:pPr lvl="4"/>
@@ -1772,7 +1777,6 @@
           <a:p>
             <a:fld id="{5BCAD085-E8A6-8845-BD4E-CB4CCA059FC4}" type="datetimeFigureOut">
               <a:rPr lang="en-US" smtClean="0"/>
-              <a:t>1/27/13</a:t>
             </a:fld>
             <a:endParaRPr lang="en-US"/>
           </a:p>
@@ -1814,18 +1818,12 @@
           <a:p>
             <a:fld id="{C1FF6DA9-008F-8B48-92A6-B652298478BF}" type="slidenum">
               <a:rPr lang="en-US" smtClean="0"/>
-              <a:t>‹#›</a:t>
             </a:fld>
             <a:endParaRPr lang="en-US"/>
           </a:p>
         </p:txBody>
       </p:sp>
     </p:spTree>
-    <p:extLst>
-      <p:ext uri="{BB962C8B-B14F-4D97-AF65-F5344CB8AC3E}">
-        <p14:creationId xmlns:p14="http://schemas.microsoft.com/office/powerpoint/2010/main" val="990158736"/>
-      </p:ext>
-    </p:extLst>
   </p:cSld>
   <p:clrMapOvr>
     <a:masterClrMapping/>
@@ -1890,7 +1888,6 @@
           <a:p>
             <a:fld id="{5BCAD085-E8A6-8845-BD4E-CB4CCA059FC4}" type="datetimeFigureOut">
               <a:rPr lang="en-US" smtClean="0"/>
-              <a:t>1/27/13</a:t>
             </a:fld>
             <a:endParaRPr lang="en-US"/>
           </a:p>
@@ -1932,18 +1929,12 @@
           <a:p>
             <a:fld id="{C1FF6DA9-008F-8B48-92A6-B652298478BF}" type="slidenum">
               <a:rPr lang="en-US" smtClean="0"/>
-              <a:t>‹#›</a:t>
             </a:fld>
             <a:endParaRPr lang="en-US"/>
           </a:p>
         </p:txBody>
       </p:sp>
     </p:spTree>
-    <p:extLst>
-      <p:ext uri="{BB962C8B-B14F-4D97-AF65-F5344CB8AC3E}">
-        <p14:creationId xmlns:p14="http://schemas.microsoft.com/office/powerpoint/2010/main" val="727027711"/>
-      </p:ext>
-    </p:extLst>
   </p:cSld>
   <p:clrMapOvr>
     <a:masterClrMapping/>
@@ -1985,7 +1976,6 @@
           <a:p>
             <a:fld id="{5BCAD085-E8A6-8845-BD4E-CB4CCA059FC4}" type="datetimeFigureOut">
               <a:rPr lang="en-US" smtClean="0"/>
-              <a:t>1/27/13</a:t>
             </a:fld>
             <a:endParaRPr lang="en-US"/>
           </a:p>
@@ -2027,18 +2017,12 @@
           <a:p>
             <a:fld id="{C1FF6DA9-008F-8B48-92A6-B652298478BF}" type="slidenum">
               <a:rPr lang="en-US" smtClean="0"/>
-              <a:t>‹#›</a:t>
             </a:fld>
             <a:endParaRPr lang="en-US"/>
           </a:p>
         </p:txBody>
       </p:sp>
     </p:spTree>
-    <p:extLst>
-      <p:ext uri="{BB962C8B-B14F-4D97-AF65-F5344CB8AC3E}">
-        <p14:creationId xmlns:p14="http://schemas.microsoft.com/office/powerpoint/2010/main" val="1212999818"/>
-      </p:ext>
-    </p:extLst>
   </p:cSld>
   <p:clrMapOvr>
     <a:masterClrMapping/>
@@ -2148,6 +2132,7 @@
               <a:rPr lang="en-US" smtClean="0"/>
               <a:t>Click to edit Master text styles</a:t>
             </a:r>
+            <a:endParaRPr lang="en-US" smtClean="0"/>
           </a:p>
           <a:p>
             <a:pPr lvl="1"/>
@@ -2155,6 +2140,7 @@
               <a:rPr lang="en-US" smtClean="0"/>
               <a:t>Second level</a:t>
             </a:r>
+            <a:endParaRPr lang="en-US" smtClean="0"/>
           </a:p>
           <a:p>
             <a:pPr lvl="2"/>
@@ -2162,6 +2148,7 @@
               <a:rPr lang="en-US" smtClean="0"/>
               <a:t>Third level</a:t>
             </a:r>
+            <a:endParaRPr lang="en-US" smtClean="0"/>
           </a:p>
           <a:p>
             <a:pPr lvl="3"/>
@@ -2169,6 +2156,7 @@
               <a:rPr lang="en-US" smtClean="0"/>
               <a:t>Fourth level</a:t>
             </a:r>
+            <a:endParaRPr lang="en-US" smtClean="0"/>
           </a:p>
           <a:p>
             <a:pPr lvl="4"/>
@@ -2242,6 +2230,7 @@
               <a:rPr lang="en-US" smtClean="0"/>
               <a:t>Click to edit Master text styles</a:t>
             </a:r>
+            <a:endParaRPr lang="en-US" smtClean="0"/>
           </a:p>
         </p:txBody>
       </p:sp>
@@ -2262,7 +2251,6 @@
           <a:p>
             <a:fld id="{5BCAD085-E8A6-8845-BD4E-CB4CCA059FC4}" type="datetimeFigureOut">
               <a:rPr lang="en-US" smtClean="0"/>
-              <a:t>1/27/13</a:t>
             </a:fld>
             <a:endParaRPr lang="en-US"/>
           </a:p>
@@ -2304,18 +2292,12 @@
           <a:p>
             <a:fld id="{C1FF6DA9-008F-8B48-92A6-B652298478BF}" type="slidenum">
               <a:rPr lang="en-US" smtClean="0"/>
-              <a:t>‹#›</a:t>
             </a:fld>
             <a:endParaRPr lang="en-US"/>
           </a:p>
         </p:txBody>
       </p:sp>
     </p:spTree>
-    <p:extLst>
-      <p:ext uri="{BB962C8B-B14F-4D97-AF65-F5344CB8AC3E}">
-        <p14:creationId xmlns:p14="http://schemas.microsoft.com/office/powerpoint/2010/main" val="1840726560"/>
-      </p:ext>
-    </p:extLst>
   </p:cSld>
   <p:clrMapOvr>
     <a:masterClrMapping/>
@@ -2495,6 +2477,7 @@
               <a:rPr lang="en-US" smtClean="0"/>
               <a:t>Click to edit Master text styles</a:t>
             </a:r>
+            <a:endParaRPr lang="en-US" smtClean="0"/>
           </a:p>
         </p:txBody>
       </p:sp>
@@ -2515,7 +2498,6 @@
           <a:p>
             <a:fld id="{5BCAD085-E8A6-8845-BD4E-CB4CCA059FC4}" type="datetimeFigureOut">
               <a:rPr lang="en-US" smtClean="0"/>
-              <a:t>1/27/13</a:t>
             </a:fld>
             <a:endParaRPr lang="en-US"/>
           </a:p>
@@ -2557,18 +2539,12 @@
           <a:p>
             <a:fld id="{C1FF6DA9-008F-8B48-92A6-B652298478BF}" type="slidenum">
               <a:rPr lang="en-US" smtClean="0"/>
-              <a:t>‹#›</a:t>
             </a:fld>
             <a:endParaRPr lang="en-US"/>
           </a:p>
         </p:txBody>
       </p:sp>
     </p:spTree>
-    <p:extLst>
-      <p:ext uri="{BB962C8B-B14F-4D97-AF65-F5344CB8AC3E}">
-        <p14:creationId xmlns:p14="http://schemas.microsoft.com/office/powerpoint/2010/main" val="3889236939"/>
-      </p:ext>
-    </p:extLst>
   </p:cSld>
   <p:clrMapOvr>
     <a:masterClrMapping/>
@@ -2661,6 +2637,7 @@
               <a:rPr lang="en-US" smtClean="0"/>
               <a:t>Click to edit Master text styles</a:t>
             </a:r>
+            <a:endParaRPr lang="en-US" smtClean="0"/>
           </a:p>
           <a:p>
             <a:pPr lvl="1"/>
@@ -2668,6 +2645,7 @@
               <a:rPr lang="en-US" smtClean="0"/>
               <a:t>Second level</a:t>
             </a:r>
+            <a:endParaRPr lang="en-US" smtClean="0"/>
           </a:p>
           <a:p>
             <a:pPr lvl="2"/>
@@ -2675,6 +2653,7 @@
               <a:rPr lang="en-US" smtClean="0"/>
               <a:t>Third level</a:t>
             </a:r>
+            <a:endParaRPr lang="en-US" smtClean="0"/>
           </a:p>
           <a:p>
             <a:pPr lvl="3"/>
@@ -2682,6 +2661,7 @@
               <a:rPr lang="en-US" smtClean="0"/>
               <a:t>Fourth level</a:t>
             </a:r>
+            <a:endParaRPr lang="en-US" smtClean="0"/>
           </a:p>
           <a:p>
             <a:pPr lvl="4"/>
@@ -2728,7 +2708,6 @@
           <a:p>
             <a:fld id="{5BCAD085-E8A6-8845-BD4E-CB4CCA059FC4}" type="datetimeFigureOut">
               <a:rPr lang="en-US" smtClean="0"/>
-              <a:t>1/27/13</a:t>
             </a:fld>
             <a:endParaRPr lang="en-US"/>
           </a:p>
@@ -2806,18 +2785,12 @@
           <a:p>
             <a:fld id="{C1FF6DA9-008F-8B48-92A6-B652298478BF}" type="slidenum">
               <a:rPr lang="en-US" smtClean="0"/>
-              <a:t>‹#›</a:t>
             </a:fld>
             <a:endParaRPr lang="en-US"/>
           </a:p>
         </p:txBody>
       </p:sp>
     </p:spTree>
-    <p:extLst>
-      <p:ext uri="{BB962C8B-B14F-4D97-AF65-F5344CB8AC3E}">
-        <p14:creationId xmlns:p14="http://schemas.microsoft.com/office/powerpoint/2010/main" val="2209977519"/>
-      </p:ext>
-    </p:extLst>
   </p:cSld>
   <p:clrMap bg1="lt1" tx1="dk1" bg2="lt2" tx2="dk2" accent1="accent1" accent2="accent2" accent3="accent3" accent4="accent4" accent5="accent5" accent6="accent6" hlink="hlink" folHlink="folHlink"/>
   <p:sldLayoutIdLst>
@@ -2855,7 +2828,7 @@
         <a:spcBef>
           <a:spcPct val="20000"/>
         </a:spcBef>
-        <a:buFont typeface="Arial"/>
+        <a:buFont typeface="Arial" panose="020B0604020202020204"/>
         <a:buChar char="•"/>
         <a:defRPr sz="3200" kern="1200">
           <a:solidFill>
@@ -2870,7 +2843,7 @@
         <a:spcBef>
           <a:spcPct val="20000"/>
         </a:spcBef>
-        <a:buFont typeface="Arial"/>
+        <a:buFont typeface="Arial" panose="020B0604020202020204"/>
         <a:buChar char="–"/>
         <a:defRPr sz="2800" kern="1200">
           <a:solidFill>
@@ -2885,7 +2858,7 @@
         <a:spcBef>
           <a:spcPct val="20000"/>
         </a:spcBef>
-        <a:buFont typeface="Arial"/>
+        <a:buFont typeface="Arial" panose="020B0604020202020204"/>
         <a:buChar char="•"/>
         <a:defRPr sz="2400" kern="1200">
           <a:solidFill>
@@ -2900,7 +2873,7 @@
         <a:spcBef>
           <a:spcPct val="20000"/>
         </a:spcBef>
-        <a:buFont typeface="Arial"/>
+        <a:buFont typeface="Arial" panose="020B0604020202020204"/>
         <a:buChar char="–"/>
         <a:defRPr sz="2000" kern="1200">
           <a:solidFill>
@@ -2915,7 +2888,7 @@
         <a:spcBef>
           <a:spcPct val="20000"/>
         </a:spcBef>
-        <a:buFont typeface="Arial"/>
+        <a:buFont typeface="Arial" panose="020B0604020202020204"/>
         <a:buChar char="»"/>
         <a:defRPr sz="2000" kern="1200">
           <a:solidFill>
@@ -2930,7 +2903,7 @@
         <a:spcBef>
           <a:spcPct val="20000"/>
         </a:spcBef>
-        <a:buFont typeface="Arial"/>
+        <a:buFont typeface="Arial" panose="020B0604020202020204"/>
         <a:buChar char="•"/>
         <a:defRPr sz="2000" kern="1200">
           <a:solidFill>
@@ -2945,7 +2918,7 @@
         <a:spcBef>
           <a:spcPct val="20000"/>
         </a:spcBef>
-        <a:buFont typeface="Arial"/>
+        <a:buFont typeface="Arial" panose="020B0604020202020204"/>
         <a:buChar char="•"/>
         <a:defRPr sz="2000" kern="1200">
           <a:solidFill>
@@ -2960,7 +2933,7 @@
         <a:spcBef>
           <a:spcPct val="20000"/>
         </a:spcBef>
-        <a:buFont typeface="Arial"/>
+        <a:buFont typeface="Arial" panose="020B0604020202020204"/>
         <a:buChar char="•"/>
         <a:defRPr sz="2000" kern="1200">
           <a:solidFill>
@@ -2975,7 +2948,7 @@
         <a:spcBef>
           <a:spcPct val="20000"/>
         </a:spcBef>
-        <a:buFont typeface="Arial"/>
+        <a:buFont typeface="Arial" panose="020B0604020202020204"/>
         <a:buChar char="•"/>
         <a:defRPr sz="2000" kern="1200">
           <a:solidFill>
@@ -3087,7 +3060,7 @@
 </file>
 
 <file path=ppt/slides/slide1.xml><?xml version="1.0" encoding="utf-8"?>
-<p:sld xmlns:a="http://schemas.openxmlformats.org/drawingml/2006/main" xmlns:p="http://schemas.openxmlformats.org/presentationml/2006/main" xmlns:r="http://schemas.openxmlformats.org/officeDocument/2006/relationships">
+<p:sld xmlns:a="http://schemas.openxmlformats.org/drawingml/2006/main" xmlns:r="http://schemas.openxmlformats.org/officeDocument/2006/relationships" xmlns:p="http://schemas.openxmlformats.org/presentationml/2006/main">
   <p:cSld>
     <p:spTree>
       <p:nvGrpSpPr>
@@ -3300,6 +3273,11 @@
               </a:rPr>
               <a:t>EHR</a:t>
             </a:r>
+            <a:endParaRPr sz="4400" b="1">
+              <a:solidFill>
+                <a:srgbClr val="38BDF8"/>
+              </a:solidFill>
+            </a:endParaRPr>
           </a:p>
           <a:p>
             <a:pPr>
@@ -3341,7 +3319,7 @@
           <a:lstStyle/>
           <a:p>
             <a:r>
-              <a:rPr b="1" sz="1100">
+              <a:rPr sz="1100" b="1">
                 <a:solidFill>
                   <a:srgbClr val="E2E8F0"/>
                 </a:solidFill>
@@ -3356,6 +3334,11 @@
               </a:rPr>
               <a:t> LOINC-coded lab &amp; imaging requisitions with STAT priority queues.</a:t>
             </a:r>
+            <a:endParaRPr sz="1100">
+              <a:solidFill>
+                <a:srgbClr val="94A3B8"/>
+              </a:solidFill>
+            </a:endParaRPr>
           </a:p>
           <a:p>
             <a:pPr>
@@ -3364,7 +3347,7 @@
               </a:spcBef>
             </a:pPr>
             <a:r>
-              <a:rPr b="1" sz="1100">
+              <a:rPr sz="1100" b="1">
                 <a:solidFill>
                   <a:srgbClr val="E2E8F0"/>
                 </a:solidFill>
@@ -3379,6 +3362,11 @@
               </a:rPr>
               <a:t> Automated drug-drug interaction &amp; allergy contraindication safeguards.</a:t>
             </a:r>
+            <a:endParaRPr sz="1100">
+              <a:solidFill>
+                <a:srgbClr val="94A3B8"/>
+              </a:solidFill>
+            </a:endParaRPr>
           </a:p>
           <a:p>
             <a:pPr>
@@ -3387,7 +3375,7 @@
               </a:spcBef>
             </a:pPr>
             <a:r>
-              <a:rPr b="1" sz="1100">
+              <a:rPr sz="1100" b="1">
                 <a:solidFill>
                   <a:srgbClr val="E2E8F0"/>
                 </a:solidFill>
@@ -3402,6 +3390,11 @@
               </a:rPr>
               <a:t> Standardized medical history &amp; cryptographically locked physician notes.</a:t>
             </a:r>
+            <a:endParaRPr sz="1100">
+              <a:solidFill>
+                <a:srgbClr val="94A3B8"/>
+              </a:solidFill>
+            </a:endParaRPr>
           </a:p>
           <a:p>
             <a:pPr>
@@ -3410,7 +3403,7 @@
               </a:spcBef>
             </a:pPr>
             <a:r>
-              <a:rPr b="1" sz="1100">
+              <a:rPr sz="1100" b="1">
                 <a:solidFill>
                   <a:srgbClr val="E2E8F0"/>
                 </a:solidFill>
@@ -3425,6 +3418,11 @@
               </a:rPr>
               <a:t> Lifetime MRN self-service vitals, medication cards &amp; lab results.</a:t>
             </a:r>
+            <a:endParaRPr sz="1100">
+              <a:solidFill>
+                <a:srgbClr val="94A3B8"/>
+              </a:solidFill>
+            </a:endParaRPr>
           </a:p>
         </p:txBody>
       </p:sp>
@@ -3547,7 +3545,7 @@
           <p:nvPr/>
         </p:nvPicPr>
         <p:blipFill>
-          <a:blip r:embed="rId2"/>
+          <a:blip r:embed="rId1"/>
           <a:stretch>
             <a:fillRect/>
           </a:stretch>
@@ -3651,7 +3649,7 @@
 </file>
 
 <file path=ppt/slides/slide2.xml><?xml version="1.0" encoding="utf-8"?>
-<p:sld xmlns:a="http://schemas.openxmlformats.org/drawingml/2006/main" xmlns:p="http://schemas.openxmlformats.org/presentationml/2006/main" xmlns:r="http://schemas.openxmlformats.org/officeDocument/2006/relationships">
+<p:sld xmlns:a="http://schemas.openxmlformats.org/drawingml/2006/main" xmlns:r="http://schemas.openxmlformats.org/officeDocument/2006/relationships" xmlns:p="http://schemas.openxmlformats.org/presentationml/2006/main">
   <p:cSld>
     <p:spTree>
       <p:nvGrpSpPr>
@@ -3860,7 +3858,7 @@
               </a:spcBef>
             </a:pPr>
             <a:r>
-              <a:rPr b="1" sz="1200">
+              <a:rPr sz="1200" b="1">
                 <a:solidFill>
                   <a:srgbClr val="0F172A"/>
                 </a:solidFill>
@@ -3875,6 +3873,11 @@
               </a:rPr>
               <a:t> Illegible physician handwriting causes life-threatening medication administration errors.</a:t>
             </a:r>
+            <a:endParaRPr sz="1200">
+              <a:solidFill>
+                <a:srgbClr val="64748B"/>
+              </a:solidFill>
+            </a:endParaRPr>
           </a:p>
           <a:p>
             <a:pPr>
@@ -3883,7 +3886,7 @@
               </a:spcBef>
             </a:pPr>
             <a:r>
-              <a:rPr b="1" sz="1200">
+              <a:rPr sz="1200" b="1">
                 <a:solidFill>
                   <a:srgbClr val="0F172A"/>
                 </a:solidFill>
@@ -3898,6 +3901,11 @@
               </a:rPr>
               <a:t> No automated checks when co-prescribing drugs like Warfarin and Aspirin (bleeding risk).</a:t>
             </a:r>
+            <a:endParaRPr sz="1200">
+              <a:solidFill>
+                <a:srgbClr val="64748B"/>
+              </a:solidFill>
+            </a:endParaRPr>
           </a:p>
           <a:p>
             <a:pPr>
@@ -3906,7 +3914,7 @@
               </a:spcBef>
             </a:pPr>
             <a:r>
-              <a:rPr b="1" sz="1200">
+              <a:rPr sz="1200" b="1">
                 <a:solidFill>
                   <a:srgbClr val="0F172A"/>
                 </a:solidFill>
@@ -3921,6 +3929,11 @@
               </a:rPr>
               <a:t> Lost paper slips for lab/radiology increase Lab Turnaround Time (TAT) and patient length-of-stay.</a:t>
             </a:r>
+            <a:endParaRPr sz="1200">
+              <a:solidFill>
+                <a:srgbClr val="64748B"/>
+              </a:solidFill>
+            </a:endParaRPr>
           </a:p>
           <a:p>
             <a:pPr>
@@ -3929,7 +3942,7 @@
               </a:spcBef>
             </a:pPr>
             <a:r>
-              <a:rPr b="1" sz="1200">
+              <a:rPr sz="1200" b="1">
                 <a:solidFill>
                   <a:srgbClr val="0F172A"/>
                 </a:solidFill>
@@ -3944,6 +3957,11 @@
               </a:rPr>
               <a:t> Patients cannot review their vital histories, laboratory trends, or consult summaries remotely.</a:t>
             </a:r>
+            <a:endParaRPr sz="1200">
+              <a:solidFill>
+                <a:srgbClr val="64748B"/>
+              </a:solidFill>
+            </a:endParaRPr>
           </a:p>
           <a:p>
             <a:pPr>
@@ -3952,7 +3970,7 @@
               </a:spcBef>
             </a:pPr>
             <a:r>
-              <a:rPr b="1" sz="1200">
+              <a:rPr sz="1200" b="1">
                 <a:solidFill>
                   <a:srgbClr val="0F172A"/>
                 </a:solidFill>
@@ -3967,6 +3985,11 @@
               </a:rPr>
               <a:t> Non-compliance with HIPAA standards for tracking who viewed or altered medical charts.</a:t>
             </a:r>
+            <a:endParaRPr sz="1200">
+              <a:solidFill>
+                <a:srgbClr val="64748B"/>
+              </a:solidFill>
+            </a:endParaRPr>
           </a:p>
         </p:txBody>
       </p:sp>
@@ -4055,7 +4078,7 @@
               </a:spcBef>
             </a:pPr>
             <a:r>
-              <a:rPr b="1" sz="1200">
+              <a:rPr sz="1200" b="1">
                 <a:solidFill>
                   <a:srgbClr val="0F172A"/>
                 </a:solidFill>
@@ -4070,6 +4093,11 @@
               </a:rPr>
               <a:t> Instant digital order routing with international LOINC diagnostic coding and STAT prioritization.</a:t>
             </a:r>
+            <a:endParaRPr sz="1200">
+              <a:solidFill>
+                <a:srgbClr val="64748B"/>
+              </a:solidFill>
+            </a:endParaRPr>
           </a:p>
           <a:p>
             <a:pPr>
@@ -4078,7 +4106,7 @@
               </a:spcBef>
             </a:pPr>
             <a:r>
-              <a:rPr b="1" sz="1200">
+              <a:rPr sz="1200" b="1">
                 <a:solidFill>
                   <a:srgbClr val="0F172A"/>
                 </a:solidFill>
@@ -4093,6 +4121,11 @@
               </a:rPr>
               <a:t> Real-time clinical decision engine scanning drug-drug interactions and allergies prior to signature.</a:t>
             </a:r>
+            <a:endParaRPr sz="1200">
+              <a:solidFill>
+                <a:srgbClr val="64748B"/>
+              </a:solidFill>
+            </a:endParaRPr>
           </a:p>
           <a:p>
             <a:pPr>
@@ -4101,7 +4134,7 @@
               </a:spcBef>
             </a:pPr>
             <a:r>
-              <a:rPr b="1" sz="1200">
+              <a:rPr sz="1200" b="1">
                 <a:solidFill>
                   <a:srgbClr val="0F172A"/>
                 </a:solidFill>
@@ -4116,6 +4149,11 @@
               </a:rPr>
               <a:t> Standardized clinical histories locked with digital clinician authentication.</a:t>
             </a:r>
+            <a:endParaRPr sz="1200">
+              <a:solidFill>
+                <a:srgbClr val="64748B"/>
+              </a:solidFill>
+            </a:endParaRPr>
           </a:p>
           <a:p>
             <a:pPr>
@@ -4124,7 +4162,7 @@
               </a:spcBef>
             </a:pPr>
             <a:r>
-              <a:rPr b="1" sz="1200">
+              <a:rPr sz="1200" b="1">
                 <a:solidFill>
                   <a:srgbClr val="0F172A"/>
                 </a:solidFill>
@@ -4139,6 +4177,11 @@
               </a:rPr>
               <a:t> Direct patient empowerment with real-time vitals flowsheets, lab releases, and active Rx cards.</a:t>
             </a:r>
+            <a:endParaRPr sz="1200">
+              <a:solidFill>
+                <a:srgbClr val="64748B"/>
+              </a:solidFill>
+            </a:endParaRPr>
           </a:p>
           <a:p>
             <a:pPr>
@@ -4147,7 +4190,7 @@
               </a:spcBef>
             </a:pPr>
             <a:r>
-              <a:rPr b="1" sz="1200">
+              <a:rPr sz="1200" b="1">
                 <a:solidFill>
                   <a:srgbClr val="0F172A"/>
                 </a:solidFill>
@@ -4162,6 +4205,11 @@
               </a:rPr>
               <a:t> Immutable audit trail capturing every chart view, order issuance, and clinician login with remote IP.</a:t>
             </a:r>
+            <a:endParaRPr sz="1200">
+              <a:solidFill>
+                <a:srgbClr val="64748B"/>
+              </a:solidFill>
+            </a:endParaRPr>
           </a:p>
         </p:txBody>
       </p:sp>
@@ -4174,7 +4222,7 @@
 </file>
 
 <file path=ppt/slides/slide3.xml><?xml version="1.0" encoding="utf-8"?>
-<p:sld xmlns:a="http://schemas.openxmlformats.org/drawingml/2006/main" xmlns:p="http://schemas.openxmlformats.org/presentationml/2006/main" xmlns:r="http://schemas.openxmlformats.org/officeDocument/2006/relationships">
+<p:sld xmlns:a="http://schemas.openxmlformats.org/drawingml/2006/main" xmlns:r="http://schemas.openxmlformats.org/officeDocument/2006/relationships" xmlns:p="http://schemas.openxmlformats.org/presentationml/2006/main">
   <p:cSld>
     <p:spTree>
       <p:nvGrpSpPr>
@@ -5099,7 +5147,7 @@
 </file>
 
 <file path=ppt/slides/slide4.xml><?xml version="1.0" encoding="utf-8"?>
-<p:sld xmlns:a="http://schemas.openxmlformats.org/drawingml/2006/main" xmlns:p="http://schemas.openxmlformats.org/presentationml/2006/main" xmlns:r="http://schemas.openxmlformats.org/officeDocument/2006/relationships">
+<p:sld xmlns:a="http://schemas.openxmlformats.org/drawingml/2006/main" xmlns:r="http://schemas.openxmlformats.org/officeDocument/2006/relationships" xmlns:p="http://schemas.openxmlformats.org/presentationml/2006/main">
   <p:cSld>
     <p:spTree>
       <p:nvGrpSpPr>
@@ -5308,7 +5356,7 @@
               </a:spcBef>
             </a:pPr>
             <a:r>
-              <a:rPr b="1" sz="1100">
+              <a:rPr sz="1100" b="1">
                 <a:solidFill>
                   <a:srgbClr val="0F172A"/>
                 </a:solidFill>
@@ -5323,6 +5371,11 @@
               </a:rPr>
               <a:t> Displays active duty shift (OPD Block B) with pulsing green live status indicator.</a:t>
             </a:r>
+            <a:endParaRPr sz="1100">
+              <a:solidFill>
+                <a:srgbClr val="64748B"/>
+              </a:solidFill>
+            </a:endParaRPr>
           </a:p>
           <a:p>
             <a:pPr>
@@ -5331,7 +5384,7 @@
               </a:spcBef>
             </a:pPr>
             <a:r>
-              <a:rPr b="1" sz="1100">
+              <a:rPr sz="1100" b="1">
                 <a:solidFill>
                   <a:srgbClr val="0F172A"/>
                 </a:solidFill>
@@ -5346,6 +5399,11 @@
               </a:rPr>
               <a:t> Monospace real-time clock updating every second via Angular ChangeDetectorRef.</a:t>
             </a:r>
+            <a:endParaRPr sz="1100">
+              <a:solidFill>
+                <a:srgbClr val="64748B"/>
+              </a:solidFill>
+            </a:endParaRPr>
           </a:p>
           <a:p>
             <a:pPr>
@@ -5354,7 +5412,7 @@
               </a:spcBef>
             </a:pPr>
             <a:r>
-              <a:rPr b="1" sz="1100">
+              <a:rPr sz="1100" b="1">
                 <a:solidFill>
                   <a:srgbClr val="0F172A"/>
                 </a:solidFill>
@@ -5369,6 +5427,11 @@
               </a:rPr>
               <a:t> Live telemetry tracking available ward and intensive care unit capacities.</a:t>
             </a:r>
+            <a:endParaRPr sz="1100">
+              <a:solidFill>
+                <a:srgbClr val="64748B"/>
+              </a:solidFill>
+            </a:endParaRPr>
           </a:p>
           <a:p>
             <a:pPr>
@@ -5377,7 +5440,7 @@
               </a:spcBef>
             </a:pPr>
             <a:r>
-              <a:rPr b="1" sz="1100">
+              <a:rPr sz="1100" b="1">
                 <a:solidFill>
                   <a:srgbClr val="0F172A"/>
                 </a:solidFill>
@@ -5392,6 +5455,11 @@
               </a:rPr>
               <a:t> Performance metric measuring swiftness of diagnostic reporting from labs to doctors.</a:t>
             </a:r>
+            <a:endParaRPr sz="1100">
+              <a:solidFill>
+                <a:srgbClr val="64748B"/>
+              </a:solidFill>
+            </a:endParaRPr>
           </a:p>
           <a:p>
             <a:pPr>
@@ -5400,7 +5468,7 @@
               </a:spcBef>
             </a:pPr>
             <a:r>
-              <a:rPr b="1" sz="1100">
+              <a:rPr sz="1100" b="1">
                 <a:solidFill>
                   <a:srgbClr val="0F172A"/>
                 </a:solidFill>
@@ -5415,6 +5483,11 @@
               </a:rPr>
               <a:t> Real-time clinical decision engine preventing concurrent contraindications.</a:t>
             </a:r>
+            <a:endParaRPr sz="1100">
+              <a:solidFill>
+                <a:srgbClr val="64748B"/>
+              </a:solidFill>
+            </a:endParaRPr>
           </a:p>
           <a:p>
             <a:pPr>
@@ -5423,7 +5496,7 @@
               </a:spcBef>
             </a:pPr>
             <a:r>
-              <a:rPr b="1" sz="1100">
+              <a:rPr sz="1100" b="1">
                 <a:solidFill>
                   <a:srgbClr val="0F172A"/>
                 </a:solidFill>
@@ -5438,6 +5511,11 @@
               </a:rPr>
               <a:t> One-click jump to Patient Directory, CPOE Labs, E-Prescribe, and SOAP Notes.</a:t>
             </a:r>
+            <a:endParaRPr sz="1100">
+              <a:solidFill>
+                <a:srgbClr val="64748B"/>
+              </a:solidFill>
+            </a:endParaRPr>
           </a:p>
         </p:txBody>
       </p:sp>
@@ -5450,7 +5528,7 @@
           <p:nvPr/>
         </p:nvPicPr>
         <p:blipFill>
-          <a:blip r:embed="rId2"/>
+          <a:blip r:embed="rId1"/>
           <a:stretch>
             <a:fillRect/>
           </a:stretch>
@@ -5554,7 +5632,7 @@
 </file>
 
 <file path=ppt/slides/slide5.xml><?xml version="1.0" encoding="utf-8"?>
-<p:sld xmlns:a="http://schemas.openxmlformats.org/drawingml/2006/main" xmlns:p="http://schemas.openxmlformats.org/presentationml/2006/main" xmlns:r="http://schemas.openxmlformats.org/officeDocument/2006/relationships">
+<p:sld xmlns:a="http://schemas.openxmlformats.org/drawingml/2006/main" xmlns:r="http://schemas.openxmlformats.org/officeDocument/2006/relationships" xmlns:p="http://schemas.openxmlformats.org/presentationml/2006/main">
   <p:cSld>
     <p:spTree>
       <p:nvGrpSpPr>
@@ -5687,7 +5765,7 @@
           <p:nvPr/>
         </p:nvPicPr>
         <p:blipFill>
-          <a:blip r:embed="rId2"/>
+          <a:blip r:embed="rId1"/>
           <a:stretch>
             <a:fillRect/>
           </a:stretch>
@@ -5787,7 +5865,7 @@
               </a:spcBef>
             </a:pPr>
             <a:r>
-              <a:rPr b="1" sz="1100">
+              <a:rPr sz="1100" b="1">
                 <a:solidFill>
                   <a:srgbClr val="0F172A"/>
                 </a:solidFill>
@@ -5802,6 +5880,11 @@
               </a:rPr>
               <a:t> Every lab &amp; imaging test uses international LOINC standards (e.g., 57698-3 for Lipid Panel, 36554-4 for Chest X-Ray).</a:t>
             </a:r>
+            <a:endParaRPr sz="1100">
+              <a:solidFill>
+                <a:srgbClr val="64748B"/>
+              </a:solidFill>
+            </a:endParaRPr>
           </a:p>
           <a:p>
             <a:pPr>
@@ -5810,7 +5893,7 @@
               </a:spcBef>
             </a:pPr>
             <a:r>
-              <a:rPr b="1" sz="1100">
+              <a:rPr sz="1100" b="1">
                 <a:solidFill>
                   <a:srgbClr val="0F172A"/>
                 </a:solidFill>
@@ -5825,6 +5908,11 @@
               </a:rPr>
               <a:t> Support for ROUTINE, URGENT, and emergency STAT queues to accelerate critical lab samples.</a:t>
             </a:r>
+            <a:endParaRPr sz="1100">
+              <a:solidFill>
+                <a:srgbClr val="64748B"/>
+              </a:solidFill>
+            </a:endParaRPr>
           </a:p>
           <a:p>
             <a:pPr>
@@ -5833,7 +5921,7 @@
               </a:spcBef>
             </a:pPr>
             <a:r>
-              <a:rPr b="1" sz="1100">
+              <a:rPr sz="1100" b="1">
                 <a:solidFill>
                   <a:srgbClr val="0F172A"/>
                 </a:solidFill>
@@ -5848,6 +5936,11 @@
               </a:rPr>
               <a:t> Doctors specify diagnostic justifications (e.g. 'high fever and weakness evaluation').</a:t>
             </a:r>
+            <a:endParaRPr sz="1100">
+              <a:solidFill>
+                <a:srgbClr val="64748B"/>
+              </a:solidFill>
+            </a:endParaRPr>
           </a:p>
           <a:p>
             <a:pPr>
@@ -5856,7 +5949,7 @@
               </a:spcBef>
             </a:pPr>
             <a:r>
-              <a:rPr b="1" sz="1100">
+              <a:rPr sz="1100" b="1">
                 <a:solidFill>
                   <a:srgbClr val="0F172A"/>
                 </a:solidFill>
@@ -5871,6 +5964,11 @@
               </a:rPr>
               <a:t> Lab techs and radiologists record quantitative results and biological normal ranges.</a:t>
             </a:r>
+            <a:endParaRPr sz="1100">
+              <a:solidFill>
+                <a:srgbClr val="64748B"/>
+              </a:solidFill>
+            </a:endParaRPr>
           </a:p>
           <a:p>
             <a:pPr>
@@ -5879,7 +5977,7 @@
               </a:spcBef>
             </a:pPr>
             <a:r>
-              <a:rPr b="1" sz="1100">
+              <a:rPr sz="1100" b="1">
                 <a:solidFill>
                   <a:srgbClr val="0F172A"/>
                 </a:solidFill>
@@ -5894,6 +5992,11 @@
               </a:rPr>
               <a:t> One-click abnormal flag highlights critical results in red on doctor worklists and hospital telemetry.</a:t>
             </a:r>
+            <a:endParaRPr sz="1100">
+              <a:solidFill>
+                <a:srgbClr val="64748B"/>
+              </a:solidFill>
+            </a:endParaRPr>
           </a:p>
         </p:txBody>
       </p:sp>
@@ -5906,7 +6009,7 @@
 </file>
 
 <file path=ppt/slides/slide6.xml><?xml version="1.0" encoding="utf-8"?>
-<p:sld xmlns:a="http://schemas.openxmlformats.org/drawingml/2006/main" xmlns:p="http://schemas.openxmlformats.org/presentationml/2006/main" xmlns:r="http://schemas.openxmlformats.org/officeDocument/2006/relationships">
+<p:sld xmlns:a="http://schemas.openxmlformats.org/drawingml/2006/main" xmlns:r="http://schemas.openxmlformats.org/officeDocument/2006/relationships" xmlns:p="http://schemas.openxmlformats.org/presentationml/2006/main">
   <p:cSld>
     <p:spTree>
       <p:nvGrpSpPr>
@@ -6504,7 +6607,7 @@
 </file>
 
 <file path=ppt/slides/slide7.xml><?xml version="1.0" encoding="utf-8"?>
-<p:sld xmlns:a="http://schemas.openxmlformats.org/drawingml/2006/main" xmlns:p="http://schemas.openxmlformats.org/presentationml/2006/main" xmlns:r="http://schemas.openxmlformats.org/officeDocument/2006/relationships">
+<p:sld xmlns:a="http://schemas.openxmlformats.org/drawingml/2006/main" xmlns:r="http://schemas.openxmlformats.org/officeDocument/2006/relationships" xmlns:p="http://schemas.openxmlformats.org/presentationml/2006/main">
   <p:cSld>
     <p:spTree>
       <p:nvGrpSpPr>
@@ -6713,7 +6816,7 @@
               </a:spcBef>
             </a:pPr>
             <a:r>
-              <a:rPr b="1" sz="1100">
+              <a:rPr sz="1100" b="1">
                 <a:solidFill>
                   <a:srgbClr val="0F172A"/>
                 </a:solidFill>
@@ -6728,6 +6831,11 @@
               </a:rPr>
               <a:t> Automated generation of lifetime identifier (e.g. MRN-7061 for Anurag Dwivedi).</a:t>
             </a:r>
+            <a:endParaRPr sz="1100">
+              <a:solidFill>
+                <a:srgbClr val="64748B"/>
+              </a:solidFill>
+            </a:endParaRPr>
           </a:p>
           <a:p>
             <a:pPr>
@@ -6736,7 +6844,7 @@
               </a:spcBef>
             </a:pPr>
             <a:r>
-              <a:rPr b="1" sz="1100">
+              <a:rPr sz="1100" b="1">
                 <a:solidFill>
                   <a:srgbClr val="0F172A"/>
                 </a:solidFill>
@@ -6751,6 +6859,11 @@
               </a:rPr>
               <a:t> Patients track historical trends of Blood Pressure, Heart Rate, SpO2, and WHO BMI status.</a:t>
             </a:r>
+            <a:endParaRPr sz="1100">
+              <a:solidFill>
+                <a:srgbClr val="64748B"/>
+              </a:solidFill>
+            </a:endParaRPr>
           </a:p>
           <a:p>
             <a:pPr>
@@ -6759,7 +6872,7 @@
               </a:spcBef>
             </a:pPr>
             <a:r>
-              <a:rPr b="1" sz="1100">
+              <a:rPr sz="1100" b="1">
                 <a:solidFill>
                   <a:srgbClr val="0F172A"/>
                 </a:solidFill>
@@ -6774,6 +6887,11 @@
               </a:rPr>
               <a:t> Complete visibility into completed blood panels and radiology impressions.</a:t>
             </a:r>
+            <a:endParaRPr sz="1100">
+              <a:solidFill>
+                <a:srgbClr val="64748B"/>
+              </a:solidFill>
+            </a:endParaRPr>
           </a:p>
           <a:p>
             <a:pPr>
@@ -6782,7 +6900,7 @@
               </a:spcBef>
             </a:pPr>
             <a:r>
-              <a:rPr b="1" sz="1100">
+              <a:rPr sz="1100" b="1">
                 <a:solidFill>
                   <a:srgbClr val="0F172A"/>
                 </a:solidFill>
@@ -6797,6 +6915,11 @@
               </a:rPr>
               <a:t> Clear dosage, frequency, and instructions to ensure medication adherence.</a:t>
             </a:r>
+            <a:endParaRPr sz="1100">
+              <a:solidFill>
+                <a:srgbClr val="64748B"/>
+              </a:solidFill>
+            </a:endParaRPr>
           </a:p>
           <a:p>
             <a:pPr>
@@ -6805,7 +6928,7 @@
               </a:spcBef>
             </a:pPr>
             <a:r>
-              <a:rPr b="1" sz="1100">
+              <a:rPr sz="1100" b="1">
                 <a:solidFill>
                   <a:srgbClr val="0F172A"/>
                 </a:solidFill>
@@ -6820,6 +6943,11 @@
               </a:rPr>
               <a:t> Patients can review attending doctor advice from any internet-connected device.</a:t>
             </a:r>
+            <a:endParaRPr sz="1100">
+              <a:solidFill>
+                <a:srgbClr val="64748B"/>
+              </a:solidFill>
+            </a:endParaRPr>
           </a:p>
           <a:p>
             <a:pPr>
@@ -6828,7 +6956,7 @@
               </a:spcBef>
             </a:pPr>
             <a:r>
-              <a:rPr b="1" sz="1100">
+              <a:rPr sz="1100" b="1">
                 <a:solidFill>
                   <a:srgbClr val="0F172A"/>
                 </a:solidFill>
@@ -6843,6 +6971,11 @@
               </a:rPr>
               <a:t> Doctors and nurses can preview how records appear to any patient.</a:t>
             </a:r>
+            <a:endParaRPr sz="1100">
+              <a:solidFill>
+                <a:srgbClr val="64748B"/>
+              </a:solidFill>
+            </a:endParaRPr>
           </a:p>
         </p:txBody>
       </p:sp>
@@ -6855,7 +6988,7 @@
           <p:nvPr/>
         </p:nvPicPr>
         <p:blipFill>
-          <a:blip r:embed="rId2"/>
+          <a:blip r:embed="rId1"/>
           <a:stretch>
             <a:fillRect/>
           </a:stretch>
@@ -7069,7 +7202,7 @@
 </file>
 
 <file path=ppt/slides/slide8.xml><?xml version="1.0" encoding="utf-8"?>
-<p:sld xmlns:a="http://schemas.openxmlformats.org/drawingml/2006/main" xmlns:p="http://schemas.openxmlformats.org/presentationml/2006/main" xmlns:r="http://schemas.openxmlformats.org/officeDocument/2006/relationships">
+<p:sld xmlns:a="http://schemas.openxmlformats.org/drawingml/2006/main" xmlns:r="http://schemas.openxmlformats.org/officeDocument/2006/relationships" xmlns:p="http://schemas.openxmlformats.org/presentationml/2006/main">
   <p:cSld>
     <p:spTree>
       <p:nvGrpSpPr>
@@ -7278,7 +7411,7 @@
               </a:spcBef>
             </a:pPr>
             <a:r>
-              <a:rPr b="1" sz="1100">
+              <a:rPr sz="1100" b="1">
                 <a:solidFill>
                   <a:srgbClr val="0F172A"/>
                 </a:solidFill>
@@ -7293,6 +7426,11 @@
               </a:rPr>
               <a:t> Doctors have prescribing privileges; Nurses manage triage and vitals; Patients have read-only access to their charts.</a:t>
             </a:r>
+            <a:endParaRPr sz="1100">
+              <a:solidFill>
+                <a:srgbClr val="64748B"/>
+              </a:solidFill>
+            </a:endParaRPr>
           </a:p>
           <a:p>
             <a:pPr>
@@ -7301,7 +7439,7 @@
               </a:spcBef>
             </a:pPr>
             <a:r>
-              <a:rPr b="1" sz="1100">
+              <a:rPr sz="1100" b="1">
                 <a:solidFill>
                   <a:srgbClr val="0F172A"/>
                 </a:solidFill>
@@ -7316,6 +7454,11 @@
               </a:rPr>
               <a:t> Every chart view, order creation, and diagnosis entry records timestamp, user, action, and remote IP address.</a:t>
             </a:r>
+            <a:endParaRPr sz="1100">
+              <a:solidFill>
+                <a:srgbClr val="64748B"/>
+              </a:solidFill>
+            </a:endParaRPr>
           </a:p>
           <a:p>
             <a:pPr>
@@ -7324,7 +7467,7 @@
               </a:spcBef>
             </a:pPr>
             <a:r>
-              <a:rPr b="1" sz="1100">
+              <a:rPr sz="1100" b="1">
                 <a:solidFill>
                   <a:srgbClr val="0F172A"/>
                 </a:solidFill>
@@ -7339,6 +7482,11 @@
               </a:rPr>
               <a:t> Relational file-backed database ensures persistent operational durability during server restarts.</a:t>
             </a:r>
+            <a:endParaRPr sz="1100">
+              <a:solidFill>
+                <a:srgbClr val="64748B"/>
+              </a:solidFill>
+            </a:endParaRPr>
           </a:p>
           <a:p>
             <a:pPr>
@@ -7347,7 +7495,7 @@
               </a:spcBef>
             </a:pPr>
             <a:r>
-              <a:rPr b="1" sz="1100">
+              <a:rPr sz="1100" b="1">
                 <a:solidFill>
                   <a:srgbClr val="0F172A"/>
                 </a:solidFill>
@@ -7362,6 +7510,11 @@
               </a:rPr>
               <a:t> Endpoints expose only required DTO schemas to prevent accidental data leaks.</a:t>
             </a:r>
+            <a:endParaRPr sz="1100">
+              <a:solidFill>
+                <a:srgbClr val="64748B"/>
+              </a:solidFill>
+            </a:endParaRPr>
           </a:p>
         </p:txBody>
       </p:sp>
@@ -7450,7 +7603,7 @@
               </a:spcBef>
             </a:pPr>
             <a:r>
-              <a:rPr b="1" sz="1100">
+              <a:rPr sz="1100" b="1">
                 <a:solidFill>
                   <a:srgbClr val="10B981"/>
                 </a:solidFill>
@@ -7465,6 +7618,11 @@
               </a:rPr>
               <a:t> RESTful FHIR R4 standard export for seamless health data sharing between hospitals.</a:t>
             </a:r>
+            <a:endParaRPr sz="1100">
+              <a:solidFill>
+                <a:srgbClr val="0F172A"/>
+              </a:solidFill>
+            </a:endParaRPr>
           </a:p>
           <a:p>
             <a:pPr>
@@ -7473,7 +7631,7 @@
               </a:spcBef>
             </a:pPr>
             <a:r>
-              <a:rPr b="1" sz="1100">
+              <a:rPr sz="1100" b="1">
                 <a:solidFill>
                   <a:srgbClr val="10B981"/>
                 </a:solidFill>
@@ -7488,6 +7646,11 @@
               </a:rPr>
               <a:t> Ambient voice-to-text generating automated draft SOAP notes during consultations.</a:t>
             </a:r>
+            <a:endParaRPr sz="1100">
+              <a:solidFill>
+                <a:srgbClr val="0F172A"/>
+              </a:solidFill>
+            </a:endParaRPr>
           </a:p>
           <a:p>
             <a:pPr>
@@ -7496,7 +7659,7 @@
               </a:spcBef>
             </a:pPr>
             <a:r>
-              <a:rPr b="1" sz="1100">
+              <a:rPr sz="1100" b="1">
                 <a:solidFill>
                   <a:srgbClr val="10B981"/>
                 </a:solidFill>
@@ -7511,6 +7674,11 @@
               </a:rPr>
               <a:t> Integrated encrypted video calling directly inside the patient portal.</a:t>
             </a:r>
+            <a:endParaRPr sz="1100">
+              <a:solidFill>
+                <a:srgbClr val="0F172A"/>
+              </a:solidFill>
+            </a:endParaRPr>
           </a:p>
           <a:p>
             <a:pPr>
@@ -7519,7 +7687,7 @@
               </a:spcBef>
             </a:pPr>
             <a:r>
-              <a:rPr b="1" sz="1100">
+              <a:rPr sz="1100" b="1">
                 <a:solidFill>
                   <a:srgbClr val="10B981"/>
                 </a:solidFill>
@@ -7534,6 +7702,11 @@
               </a:rPr>
               <a:t> Machine learning early warning scores (NEWS2) derived from real-time vitals flowsheets.</a:t>
             </a:r>
+            <a:endParaRPr sz="1100">
+              <a:solidFill>
+                <a:srgbClr val="0F172A"/>
+              </a:solidFill>
+            </a:endParaRPr>
           </a:p>
           <a:p>
             <a:pPr>
@@ -7542,7 +7715,7 @@
               </a:spcBef>
             </a:pPr>
             <a:r>
-              <a:rPr b="1" sz="1100">
+              <a:rPr sz="1100" b="1">
                 <a:solidFill>
                   <a:srgbClr val="10B981"/>
                 </a:solidFill>
@@ -7557,6 +7730,11 @@
               </a:rPr>
               <a:t> Barcode Medication Administration (BCMA) scanning verification at bedside.</a:t>
             </a:r>
+            <a:endParaRPr sz="1100">
+              <a:solidFill>
+                <a:srgbClr val="0F172A"/>
+              </a:solidFill>
+            </a:endParaRPr>
           </a:p>
         </p:txBody>
       </p:sp>
@@ -7569,7 +7747,7 @@
 </file>
 
 <file path=ppt/slides/slide9.xml><?xml version="1.0" encoding="utf-8"?>
-<p:sld xmlns:a="http://schemas.openxmlformats.org/drawingml/2006/main" xmlns:p="http://schemas.openxmlformats.org/presentationml/2006/main" xmlns:r="http://schemas.openxmlformats.org/officeDocument/2006/relationships">
+<p:sld xmlns:a="http://schemas.openxmlformats.org/drawingml/2006/main" xmlns:r="http://schemas.openxmlformats.org/officeDocument/2006/relationships" xmlns:p="http://schemas.openxmlformats.org/presentationml/2006/main">
   <p:cSld>
     <p:spTree>
       <p:nvGrpSpPr>
@@ -7587,7 +7765,7 @@
           <p:nvPr/>
         </p:nvPicPr>
         <p:blipFill>
-          <a:blip r:embed="rId2"/>
+          <a:blip r:embed="rId1"/>
           <a:stretch>
             <a:fillRect/>
           </a:stretch>
@@ -7641,6 +7819,11 @@
               </a:rPr>
               <a:t>You.</a:t>
             </a:r>
+            <a:endParaRPr sz="7200" b="1">
+              <a:solidFill>
+                <a:srgbClr val="38BDF8"/>
+              </a:solidFill>
+            </a:endParaRPr>
           </a:p>
         </p:txBody>
       </p:sp>
@@ -7968,6 +8151,10 @@
       </a:style>
     </a:lnDef>
   </a:objectDefaults>
-  <a:extraClrSchemeLst/>
+  <a:extLst>
+    <a:ext uri="{05A4C25C-085E-4340-85A3-A5531E510DB2}">
+      <thm15:themeFamily xmlns:thm15="http://schemas.microsoft.com/office/thememl/2012/main" name="Office Theme" id="{62F939B6-93AF-4DB8-9C6B-D6C7DFDC589F}" vid="{4A3C46E8-61CC-4603-A589-7422A47A8E4A}"/>
+    </a:ext>
+  </a:extLst>
 </a:theme>
 </file>
</xml_diff>